<commit_message>
refactor: extractor improvements, PptxGenJS slides, template updates
- pathology/radiology extractors: validation, layer annotations
- tumor_markers: improved parsing and GCIG criteria
- grounded_clinical_note: safe text handling
- clinical_note_filter_utils: shared filter helpers
- PptxGenJS-based PPTX generation (tumor_board_slides.js)
- Updated Word/PPTX templates for 5-column/5-slide layout

Co-Authored-By: Claude Opus 4.6 <noreply@anthropic.com>
</commit_message>
<xml_diff>
--- a/src/scenarios/default/templates/tumor_board_slides.pptx
+++ b/src/scenarios/default/templates/tumor_board_slides.pptx
@@ -8,6 +8,8 @@
     <p:sldId id="256" r:id="rId7"/>
     <p:sldId id="257" r:id="rId8"/>
     <p:sldId id="258" r:id="rId9"/>
+    <p:sldId id="259" r:id="rId10"/>
+    <p:sldId id="260" r:id="rId11"/>
   </p:sldIdLst>
   <p:sldSz cx="12191695" cy="6858000" type="screen4x3"/>
   <p:notesSz cx="6858000" cy="9144000"/>
@@ -3107,7 +3109,7 @@
         <p:spPr>
           <a:xfrm>
             <a:off x="0" y="0"/>
-            <a:ext cx="12191695" cy="1280160"/>
+            <a:ext cx="12191695" cy="1097280"/>
           </a:xfrm>
           <a:prstGeom prst="rect">
             <a:avLst/>
@@ -3143,14 +3145,14 @@
       </p:sp>
       <p:sp>
         <p:nvSpPr>
-          <p:cNvPr id="3" name="title"/>
+          <p:cNvPr id="3" name="slide_badge"/>
           <p:cNvSpPr txBox="1"/>
           <p:nvPr/>
         </p:nvSpPr>
         <p:spPr>
           <a:xfrm>
-            <a:off x="731520" y="182880"/>
-            <a:ext cx="10058400" cy="548640"/>
+            <a:off x="11002975" y="91440"/>
+            <a:ext cx="1097280" cy="320040"/>
           </a:xfrm>
           <a:prstGeom prst="rect">
             <a:avLst/>
@@ -3158,34 +3160,34 @@
           <a:noFill/>
         </p:spPr>
         <p:txBody>
-          <a:bodyPr wrap="square">
+          <a:bodyPr wrap="none">
             <a:spAutoFit/>
           </a:bodyPr>
           <a:lstStyle/>
           <a:p>
-            <a:pPr algn="l">
-              <a:defRPr sz="3200" b="1">
-                <a:solidFill>
-                  <a:srgbClr val="FFFFFF"/>
+            <a:pPr algn="r">
+              <a:defRPr sz="1100">
+                <a:solidFill>
+                  <a:srgbClr val="007C91"/>
                 </a:solidFill>
               </a:defRPr>
             </a:pPr>
             <a:r>
-              <a:t>Patient Overview</a:t>
-            </a:r>
-          </a:p>
-        </p:txBody>
-      </p:sp>
-      <p:sp>
-        <p:nvSpPr>
-          <p:cNvPr id="4" name="subtitle"/>
+              <a:t>1 / 5</a:t>
+            </a:r>
+          </a:p>
+        </p:txBody>
+      </p:sp>
+      <p:sp>
+        <p:nvSpPr>
+          <p:cNvPr id="4" name="title"/>
           <p:cNvSpPr txBox="1"/>
           <p:nvPr/>
         </p:nvSpPr>
         <p:spPr>
           <a:xfrm>
-            <a:off x="731520" y="731520"/>
-            <a:ext cx="10058400" cy="457200"/>
+            <a:off x="731520" y="228600"/>
+            <a:ext cx="9144000" cy="548640"/>
           </a:xfrm>
           <a:prstGeom prst="rect">
             <a:avLst/>
@@ -3199,27 +3201,62 @@
           <a:lstStyle/>
           <a:p>
             <a:pPr algn="l">
-              <a:defRPr sz="1800" b="0">
+              <a:defRPr sz="3200" b="1">
+                <a:solidFill>
+                  <a:srgbClr val="FFFFFF"/>
+                </a:solidFill>
+              </a:defRPr>
+            </a:pPr>
+            <a:r>
+              <a:t>Patient</a:t>
+            </a:r>
+          </a:p>
+        </p:txBody>
+      </p:sp>
+      <p:sp>
+        <p:nvSpPr>
+          <p:cNvPr id="5" name="subtitle"/>
+          <p:cNvSpPr txBox="1"/>
+          <p:nvPr/>
+        </p:nvSpPr>
+        <p:spPr>
+          <a:xfrm>
+            <a:off x="731520" y="777240"/>
+            <a:ext cx="9144000" cy="274320"/>
+          </a:xfrm>
+          <a:prstGeom prst="rect">
+            <a:avLst/>
+          </a:prstGeom>
+          <a:noFill/>
+        </p:spPr>
+        <p:txBody>
+          <a:bodyPr wrap="square">
+            <a:spAutoFit/>
+          </a:bodyPr>
+          <a:lstStyle/>
+          <a:p>
+            <a:pPr algn="l">
+              <a:defRPr sz="1300" b="0">
                 <a:solidFill>
                   <a:srgbClr val="007C91"/>
                 </a:solidFill>
               </a:defRPr>
             </a:pPr>
             <a:r>
-              <a:t>FIGO Stage | Molecular Profile | Date</a:t>
-            </a:r>
-          </a:p>
-        </p:txBody>
-      </p:sp>
-      <p:sp>
-        <p:nvSpPr>
-          <p:cNvPr id="5" name="Rectangle 4"/>
+              <a:t>Col 0 — Case logistics</a:t>
+            </a:r>
+          </a:p>
+        </p:txBody>
+      </p:sp>
+      <p:sp>
+        <p:nvSpPr>
+          <p:cNvPr id="6" name="Rectangle 5"/>
           <p:cNvSpPr/>
           <p:nvPr/>
         </p:nvSpPr>
         <p:spPr>
           <a:xfrm>
-            <a:off x="731520" y="1463040"/>
+            <a:off x="731520" y="1234440"/>
             <a:ext cx="1371600" cy="45720"/>
           </a:xfrm>
           <a:prstGeom prst="rect">
@@ -3256,14 +3293,14 @@
       </p:sp>
       <p:sp>
         <p:nvSpPr>
-          <p:cNvPr id="6" name="body"/>
+          <p:cNvPr id="7" name="body"/>
           <p:cNvSpPr txBox="1"/>
           <p:nvPr/>
         </p:nvSpPr>
         <p:spPr>
           <a:xfrm>
-            <a:off x="731520" y="1737360"/>
-            <a:ext cx="10515600" cy="4572000"/>
+            <a:off x="731520" y="1417320"/>
+            <a:ext cx="10515600" cy="4754880"/>
           </a:xfrm>
           <a:prstGeom prst="rect">
             <a:avLst/>
@@ -3288,7 +3325,7 @@
       </p:sp>
       <p:sp>
         <p:nvSpPr>
-          <p:cNvPr id="7" name="footer"/>
+          <p:cNvPr id="8" name="footer"/>
           <p:cNvSpPr txBox="1"/>
           <p:nvPr/>
         </p:nvSpPr>
@@ -3349,7 +3386,7 @@
       <p:grpSpPr/>
       <p:sp>
         <p:nvSpPr>
-          <p:cNvPr id="2" name="Rectangle 1"/>
+          <p:cNvPr id="2" name="header_bar"/>
           <p:cNvSpPr/>
           <p:nvPr/>
         </p:nvSpPr>
@@ -3392,14 +3429,14 @@
       </p:sp>
       <p:sp>
         <p:nvSpPr>
-          <p:cNvPr id="3" name="title"/>
+          <p:cNvPr id="3" name="slide_badge"/>
           <p:cNvSpPr txBox="1"/>
           <p:nvPr/>
         </p:nvSpPr>
         <p:spPr>
           <a:xfrm>
-            <a:off x="731520" y="274320"/>
-            <a:ext cx="10058400" cy="548640"/>
+            <a:off x="11002975" y="91440"/>
+            <a:ext cx="1097280" cy="320040"/>
           </a:xfrm>
           <a:prstGeom prst="rect">
             <a:avLst/>
@@ -3407,34 +3444,34 @@
           <a:noFill/>
         </p:spPr>
         <p:txBody>
-          <a:bodyPr wrap="square">
+          <a:bodyPr wrap="none">
             <a:spAutoFit/>
           </a:bodyPr>
           <a:lstStyle/>
           <a:p>
-            <a:pPr algn="l">
-              <a:defRPr sz="2800" b="1">
-                <a:solidFill>
-                  <a:srgbClr val="FFFFFF"/>
+            <a:pPr algn="r">
+              <a:defRPr sz="1100">
+                <a:solidFill>
+                  <a:srgbClr val="007C91"/>
                 </a:solidFill>
               </a:defRPr>
             </a:pPr>
             <a:r>
-              <a:t>Clinical Findings</a:t>
-            </a:r>
-          </a:p>
-        </p:txBody>
-      </p:sp>
-      <p:sp>
-        <p:nvSpPr>
-          <p:cNvPr id="4" name="body_left"/>
+              <a:t>2 / 5</a:t>
+            </a:r>
+          </a:p>
+        </p:txBody>
+      </p:sp>
+      <p:sp>
+        <p:nvSpPr>
+          <p:cNvPr id="4" name="title"/>
           <p:cNvSpPr txBox="1"/>
           <p:nvPr/>
         </p:nvSpPr>
         <p:spPr>
           <a:xfrm>
-            <a:off x="731520" y="1371600"/>
-            <a:ext cx="5486400" cy="5029200"/>
+            <a:off x="731520" y="228600"/>
+            <a:ext cx="9144000" cy="548640"/>
           </a:xfrm>
           <a:prstGeom prst="rect">
             <a:avLst/>
@@ -3448,25 +3485,28 @@
           <a:lstStyle/>
           <a:p>
             <a:pPr algn="l">
-              <a:defRPr sz="1400" b="0">
-                <a:solidFill>
-                  <a:srgbClr val="333333"/>
+              <a:defRPr sz="2800" b="1">
+                <a:solidFill>
+                  <a:srgbClr val="FFFFFF"/>
                 </a:solidFill>
               </a:defRPr>
             </a:pPr>
-          </a:p>
-        </p:txBody>
-      </p:sp>
-      <p:sp>
-        <p:nvSpPr>
-          <p:cNvPr id="5" name="chart_title"/>
+            <a:r>
+              <a:t>Diagnosis &amp; Pertinent History</a:t>
+            </a:r>
+          </a:p>
+        </p:txBody>
+      </p:sp>
+      <p:sp>
+        <p:nvSpPr>
+          <p:cNvPr id="5" name="subtitle"/>
           <p:cNvSpPr txBox="1"/>
           <p:nvPr/>
         </p:nvSpPr>
         <p:spPr>
           <a:xfrm>
-            <a:off x="6858000" y="1371600"/>
-            <a:ext cx="4846320" cy="365760"/>
+            <a:off x="731520" y="777240"/>
+            <a:ext cx="9144000" cy="274320"/>
           </a:xfrm>
           <a:prstGeom prst="rect">
             <a:avLst/>
@@ -3479,40 +3519,38 @@
           </a:bodyPr>
           <a:lstStyle/>
           <a:p>
-            <a:pPr algn="ctr">
-              <a:defRPr sz="1400" b="1">
+            <a:pPr algn="l">
+              <a:defRPr sz="1300" b="0">
                 <a:solidFill>
                   <a:srgbClr val="007C91"/>
                 </a:solidFill>
               </a:defRPr>
             </a:pPr>
             <a:r>
-              <a:t>Tumor Marker Trend</a:t>
-            </a:r>
-          </a:p>
-        </p:txBody>
-      </p:sp>
-      <p:sp>
-        <p:nvSpPr>
-          <p:cNvPr id="6" name="chart_area"/>
+              <a:t>Col 1 — Narrative + staging</a:t>
+            </a:r>
+          </a:p>
+        </p:txBody>
+      </p:sp>
+      <p:sp>
+        <p:nvSpPr>
+          <p:cNvPr id="6" name="Rectangle 5"/>
           <p:cNvSpPr/>
           <p:nvPr/>
         </p:nvSpPr>
         <p:spPr>
           <a:xfrm>
-            <a:off x="6858000" y="1828800"/>
-            <a:ext cx="4846320" cy="4114800"/>
+            <a:off x="731520" y="1234440"/>
+            <a:ext cx="1371600" cy="45720"/>
           </a:xfrm>
           <a:prstGeom prst="rect">
             <a:avLst/>
           </a:prstGeom>
           <a:solidFill>
-            <a:srgbClr val="F5F5F5"/>
+            <a:srgbClr val="007C91"/>
           </a:solidFill>
           <a:ln>
-            <a:solidFill>
-              <a:srgbClr val="DDDDDD"/>
-            </a:solidFill>
+            <a:noFill/>
           </a:ln>
         </p:spPr>
         <p:style>
@@ -3539,7 +3577,106 @@
       </p:sp>
       <p:sp>
         <p:nvSpPr>
-          <p:cNvPr id="7" name="footer"/>
+          <p:cNvPr id="7" name="body"/>
+          <p:cNvSpPr txBox="1"/>
+          <p:nvPr/>
+        </p:nvSpPr>
+        <p:spPr>
+          <a:xfrm>
+            <a:off x="731520" y="1417320"/>
+            <a:ext cx="6858000" cy="3474720"/>
+          </a:xfrm>
+          <a:prstGeom prst="rect">
+            <a:avLst/>
+          </a:prstGeom>
+          <a:noFill/>
+        </p:spPr>
+        <p:txBody>
+          <a:bodyPr wrap="square">
+            <a:spAutoFit/>
+          </a:bodyPr>
+          <a:lstStyle/>
+          <a:p>
+            <a:pPr algn="l">
+              <a:defRPr sz="1400" b="0">
+                <a:solidFill>
+                  <a:srgbClr val="333333"/>
+                </a:solidFill>
+              </a:defRPr>
+            </a:pPr>
+          </a:p>
+        </p:txBody>
+      </p:sp>
+      <p:sp>
+        <p:nvSpPr>
+          <p:cNvPr id="8" name="staging_label"/>
+          <p:cNvSpPr txBox="1"/>
+          <p:nvPr/>
+        </p:nvSpPr>
+        <p:spPr>
+          <a:xfrm>
+            <a:off x="731520" y="5029200"/>
+            <a:ext cx="10515600" cy="320040"/>
+          </a:xfrm>
+          <a:prstGeom prst="rect">
+            <a:avLst/>
+          </a:prstGeom>
+          <a:noFill/>
+        </p:spPr>
+        <p:txBody>
+          <a:bodyPr wrap="square">
+            <a:spAutoFit/>
+          </a:bodyPr>
+          <a:lstStyle/>
+          <a:p>
+            <a:pPr algn="l">
+              <a:defRPr sz="1300" b="0">
+                <a:solidFill>
+                  <a:srgbClr val="FF0000"/>
+                </a:solidFill>
+              </a:defRPr>
+            </a:pPr>
+            <a:r>
+              <a:t>Primary Site:</a:t>
+            </a:r>
+          </a:p>
+        </p:txBody>
+      </p:sp>
+      <p:sp>
+        <p:nvSpPr>
+          <p:cNvPr id="9" name="staging_body"/>
+          <p:cNvSpPr txBox="1"/>
+          <p:nvPr/>
+        </p:nvSpPr>
+        <p:spPr>
+          <a:xfrm>
+            <a:off x="731520" y="5029200"/>
+            <a:ext cx="10515600" cy="1234440"/>
+          </a:xfrm>
+          <a:prstGeom prst="rect">
+            <a:avLst/>
+          </a:prstGeom>
+          <a:noFill/>
+        </p:spPr>
+        <p:txBody>
+          <a:bodyPr wrap="square">
+            <a:spAutoFit/>
+          </a:bodyPr>
+          <a:lstStyle/>
+          <a:p>
+            <a:pPr algn="l">
+              <a:defRPr sz="1300" b="0">
+                <a:solidFill>
+                  <a:srgbClr val="FF0000"/>
+                </a:solidFill>
+              </a:defRPr>
+            </a:pPr>
+          </a:p>
+        </p:txBody>
+      </p:sp>
+      <p:sp>
+        <p:nvSpPr>
+          <p:cNvPr id="10" name="footer"/>
           <p:cNvSpPr txBox="1"/>
           <p:nvPr/>
         </p:nvSpPr>
@@ -3600,7 +3737,7 @@
       <p:grpSpPr/>
       <p:sp>
         <p:nvSpPr>
-          <p:cNvPr id="2" name="Rectangle 1"/>
+          <p:cNvPr id="2" name="header_bar"/>
           <p:cNvSpPr/>
           <p:nvPr/>
         </p:nvSpPr>
@@ -3643,14 +3780,14 @@
       </p:sp>
       <p:sp>
         <p:nvSpPr>
-          <p:cNvPr id="3" name="title"/>
+          <p:cNvPr id="3" name="slide_badge"/>
           <p:cNvSpPr txBox="1"/>
           <p:nvPr/>
         </p:nvSpPr>
         <p:spPr>
           <a:xfrm>
-            <a:off x="731520" y="274320"/>
-            <a:ext cx="10058400" cy="548640"/>
+            <a:off x="11002975" y="91440"/>
+            <a:ext cx="1097280" cy="320040"/>
           </a:xfrm>
           <a:prstGeom prst="rect">
             <a:avLst/>
@@ -3658,27 +3795,97 @@
           <a:noFill/>
         </p:spPr>
         <p:txBody>
+          <a:bodyPr wrap="none">
+            <a:spAutoFit/>
+          </a:bodyPr>
+          <a:lstStyle/>
+          <a:p>
+            <a:pPr algn="r">
+              <a:defRPr sz="1100">
+                <a:solidFill>
+                  <a:srgbClr val="007C91"/>
+                </a:solidFill>
+              </a:defRPr>
+            </a:pPr>
+            <a:r>
+              <a:t>3 / 5</a:t>
+            </a:r>
+          </a:p>
+        </p:txBody>
+      </p:sp>
+      <p:sp>
+        <p:nvSpPr>
+          <p:cNvPr id="4" name="title"/>
+          <p:cNvSpPr txBox="1"/>
+          <p:nvPr/>
+        </p:nvSpPr>
+        <p:spPr>
+          <a:xfrm>
+            <a:off x="731520" y="228600"/>
+            <a:ext cx="9144000" cy="548640"/>
+          </a:xfrm>
+          <a:prstGeom prst="rect">
+            <a:avLst/>
+          </a:prstGeom>
+          <a:noFill/>
+        </p:spPr>
+        <p:txBody>
           <a:bodyPr wrap="square">
             <a:spAutoFit/>
           </a:bodyPr>
           <a:lstStyle/>
           <a:p>
             <a:pPr algn="l">
-              <a:defRPr sz="2800" b="1">
+              <a:defRPr sz="2600" b="1">
                 <a:solidFill>
                   <a:srgbClr val="FFFFFF"/>
                 </a:solidFill>
               </a:defRPr>
             </a:pPr>
             <a:r>
-              <a:t>Treatment Plan &amp; Clinical Trials</a:t>
-            </a:r>
-          </a:p>
-        </p:txBody>
-      </p:sp>
-      <p:sp>
-        <p:nvSpPr>
-          <p:cNvPr id="4" name="Rectangle 3"/>
+              <a:t>Previous Tx or Operative Findings</a:t>
+            </a:r>
+          </a:p>
+        </p:txBody>
+      </p:sp>
+      <p:sp>
+        <p:nvSpPr>
+          <p:cNvPr id="5" name="subtitle"/>
+          <p:cNvSpPr txBox="1"/>
+          <p:nvPr/>
+        </p:nvSpPr>
+        <p:spPr>
+          <a:xfrm>
+            <a:off x="731520" y="777240"/>
+            <a:ext cx="9144000" cy="274320"/>
+          </a:xfrm>
+          <a:prstGeom prst="rect">
+            <a:avLst/>
+          </a:prstGeom>
+          <a:noFill/>
+        </p:spPr>
+        <p:txBody>
+          <a:bodyPr wrap="square">
+            <a:spAutoFit/>
+          </a:bodyPr>
+          <a:lstStyle/>
+          <a:p>
+            <a:pPr algn="l">
+              <a:defRPr sz="1300" b="0">
+                <a:solidFill>
+                  <a:srgbClr val="007C91"/>
+                </a:solidFill>
+              </a:defRPr>
+            </a:pPr>
+            <a:r>
+              <a:t>Col 2 — Treatment history &amp; tumor markers</a:t>
+            </a:r>
+          </a:p>
+        </p:txBody>
+      </p:sp>
+      <p:sp>
+        <p:nvSpPr>
+          <p:cNvPr id="6" name="Rectangle 5"/>
           <p:cNvSpPr/>
           <p:nvPr/>
         </p:nvSpPr>
@@ -3721,14 +3928,14 @@
       </p:sp>
       <p:sp>
         <p:nvSpPr>
-          <p:cNvPr id="5" name="body"/>
+          <p:cNvPr id="7" name="body_left"/>
           <p:cNvSpPr txBox="1"/>
           <p:nvPr/>
         </p:nvSpPr>
         <p:spPr>
           <a:xfrm>
-            <a:off x="731520" y="1463040"/>
-            <a:ext cx="10515600" cy="3200400"/>
+            <a:off x="731520" y="1417320"/>
+            <a:ext cx="5486400" cy="4754880"/>
           </a:xfrm>
           <a:prstGeom prst="rect">
             <a:avLst/>
@@ -3753,14 +3960,14 @@
       </p:sp>
       <p:sp>
         <p:nvSpPr>
-          <p:cNvPr id="6" name="trials_header"/>
+          <p:cNvPr id="8" name="chart_title"/>
           <p:cNvSpPr txBox="1"/>
           <p:nvPr/>
         </p:nvSpPr>
         <p:spPr>
           <a:xfrm>
-            <a:off x="731520" y="4754880"/>
-            <a:ext cx="10515600" cy="365760"/>
+            <a:off x="6858000" y="1417320"/>
+            <a:ext cx="4846320" cy="365760"/>
           </a:xfrm>
           <a:prstGeom prst="rect">
             <a:avLst/>
@@ -3773,29 +3980,74 @@
           </a:bodyPr>
           <a:lstStyle/>
           <a:p>
-            <a:pPr algn="l">
-              <a:defRPr sz="1600" b="1">
+            <a:pPr algn="ctr">
+              <a:defRPr sz="1400" b="1">
                 <a:solidFill>
                   <a:srgbClr val="007C91"/>
                 </a:solidFill>
               </a:defRPr>
             </a:pPr>
             <a:r>
-              <a:t>Eligible Clinical Trials</a:t>
-            </a:r>
-          </a:p>
-        </p:txBody>
-      </p:sp>
-      <p:sp>
-        <p:nvSpPr>
-          <p:cNvPr id="7" name="trials_body"/>
+              <a:t>CA-125 Trend</a:t>
+            </a:r>
+          </a:p>
+        </p:txBody>
+      </p:sp>
+      <p:sp>
+        <p:nvSpPr>
+          <p:cNvPr id="9" name="chart_area"/>
+          <p:cNvSpPr/>
+          <p:nvPr/>
+        </p:nvSpPr>
+        <p:spPr>
+          <a:xfrm>
+            <a:off x="6858000" y="1874519"/>
+            <a:ext cx="4846320" cy="4114800"/>
+          </a:xfrm>
+          <a:prstGeom prst="rect">
+            <a:avLst/>
+          </a:prstGeom>
+          <a:solidFill>
+            <a:srgbClr val="F5F5F5"/>
+          </a:solidFill>
+          <a:ln>
+            <a:solidFill>
+              <a:srgbClr val="DDDDDD"/>
+            </a:solidFill>
+          </a:ln>
+        </p:spPr>
+        <p:style>
+          <a:lnRef idx="1">
+            <a:schemeClr val="accent1"/>
+          </a:lnRef>
+          <a:fillRef idx="3">
+            <a:schemeClr val="accent1"/>
+          </a:fillRef>
+          <a:effectRef idx="2">
+            <a:schemeClr val="accent1"/>
+          </a:effectRef>
+          <a:fontRef idx="minor">
+            <a:schemeClr val="lt1"/>
+          </a:fontRef>
+        </p:style>
+        <p:txBody>
+          <a:bodyPr rtlCol="0" anchor="ctr"/>
+          <a:lstStyle/>
+          <a:p>
+            <a:pPr algn="ctr"/>
+          </a:p>
+        </p:txBody>
+      </p:sp>
+      <p:sp>
+        <p:nvSpPr>
+          <p:cNvPr id="10" name="footer"/>
           <p:cNvSpPr txBox="1"/>
           <p:nvPr/>
         </p:nvSpPr>
         <p:spPr>
           <a:xfrm>
-            <a:off x="731520" y="5212080"/>
-            <a:ext cx="10515600" cy="1097280"/>
+            <a:off x="731520" y="6400800"/>
+            <a:ext cx="10515600" cy="365760"/>
           </a:xfrm>
           <a:prstGeom prst="rect">
             <a:avLst/>
@@ -3808,9 +4060,261 @@
           </a:bodyPr>
           <a:lstStyle/>
           <a:p>
+            <a:pPr algn="ctr">
+              <a:defRPr sz="1000" b="0">
+                <a:solidFill>
+                  <a:srgbClr val="999999"/>
+                </a:solidFill>
+              </a:defRPr>
+            </a:pPr>
+            <a:r>
+              <a:t>GYN Oncology Tumor Board</a:t>
+            </a:r>
+          </a:p>
+        </p:txBody>
+      </p:sp>
+    </p:spTree>
+  </p:cSld>
+  <p:clrMapOvr>
+    <a:masterClrMapping/>
+  </p:clrMapOvr>
+</p:sld>
+</file>
+
+<file path=ppt/slides/slide4.xml><?xml version="1.0" encoding="utf-8"?>
+<p:sld xmlns:a="http://schemas.openxmlformats.org/drawingml/2006/main" xmlns:p="http://schemas.openxmlformats.org/presentationml/2006/main" xmlns:r="http://schemas.openxmlformats.org/officeDocument/2006/relationships">
+  <p:cSld>
+    <p:bg>
+      <p:bgPr>
+        <a:solidFill>
+          <a:srgbClr val="FFFFFF"/>
+        </a:solidFill>
+        <a:effectLst/>
+      </p:bgPr>
+    </p:bg>
+    <p:spTree>
+      <p:nvGrpSpPr>
+        <p:cNvPr id="1" name=""/>
+        <p:cNvGrpSpPr/>
+        <p:nvPr/>
+      </p:nvGrpSpPr>
+      <p:grpSpPr/>
+      <p:sp>
+        <p:nvSpPr>
+          <p:cNvPr id="2" name="header_bar"/>
+          <p:cNvSpPr/>
+          <p:nvPr/>
+        </p:nvSpPr>
+        <p:spPr>
+          <a:xfrm>
+            <a:off x="0" y="0"/>
+            <a:ext cx="12191695" cy="1097280"/>
+          </a:xfrm>
+          <a:prstGeom prst="rect">
+            <a:avLst/>
+          </a:prstGeom>
+          <a:solidFill>
+            <a:srgbClr val="1B365D"/>
+          </a:solidFill>
+          <a:ln>
+            <a:noFill/>
+          </a:ln>
+        </p:spPr>
+        <p:style>
+          <a:lnRef idx="1">
+            <a:schemeClr val="accent1"/>
+          </a:lnRef>
+          <a:fillRef idx="3">
+            <a:schemeClr val="accent1"/>
+          </a:fillRef>
+          <a:effectRef idx="2">
+            <a:schemeClr val="accent1"/>
+          </a:effectRef>
+          <a:fontRef idx="minor">
+            <a:schemeClr val="lt1"/>
+          </a:fontRef>
+        </p:style>
+        <p:txBody>
+          <a:bodyPr rtlCol="0" anchor="ctr"/>
+          <a:lstStyle/>
+          <a:p>
+            <a:pPr algn="ctr"/>
+          </a:p>
+        </p:txBody>
+      </p:sp>
+      <p:sp>
+        <p:nvSpPr>
+          <p:cNvPr id="3" name="slide_badge"/>
+          <p:cNvSpPr txBox="1"/>
+          <p:nvPr/>
+        </p:nvSpPr>
+        <p:spPr>
+          <a:xfrm>
+            <a:off x="11002975" y="91440"/>
+            <a:ext cx="1097280" cy="320040"/>
+          </a:xfrm>
+          <a:prstGeom prst="rect">
+            <a:avLst/>
+          </a:prstGeom>
+          <a:noFill/>
+        </p:spPr>
+        <p:txBody>
+          <a:bodyPr wrap="none">
+            <a:spAutoFit/>
+          </a:bodyPr>
+          <a:lstStyle/>
+          <a:p>
+            <a:pPr algn="r">
+              <a:defRPr sz="1100">
+                <a:solidFill>
+                  <a:srgbClr val="007C91"/>
+                </a:solidFill>
+              </a:defRPr>
+            </a:pPr>
+            <a:r>
+              <a:t>4 / 5</a:t>
+            </a:r>
+          </a:p>
+        </p:txBody>
+      </p:sp>
+      <p:sp>
+        <p:nvSpPr>
+          <p:cNvPr id="4" name="title"/>
+          <p:cNvSpPr txBox="1"/>
+          <p:nvPr/>
+        </p:nvSpPr>
+        <p:spPr>
+          <a:xfrm>
+            <a:off x="731520" y="228600"/>
+            <a:ext cx="9144000" cy="548640"/>
+          </a:xfrm>
+          <a:prstGeom prst="rect">
+            <a:avLst/>
+          </a:prstGeom>
+          <a:noFill/>
+        </p:spPr>
+        <p:txBody>
+          <a:bodyPr wrap="square">
+            <a:spAutoFit/>
+          </a:bodyPr>
+          <a:lstStyle/>
+          <a:p>
+            <a:pPr algn="l">
+              <a:defRPr sz="3200" b="1">
+                <a:solidFill>
+                  <a:srgbClr val="FFFFFF"/>
+                </a:solidFill>
+              </a:defRPr>
+            </a:pPr>
+            <a:r>
+              <a:t>Imaging</a:t>
+            </a:r>
+          </a:p>
+        </p:txBody>
+      </p:sp>
+      <p:sp>
+        <p:nvSpPr>
+          <p:cNvPr id="5" name="subtitle"/>
+          <p:cNvSpPr txBox="1"/>
+          <p:nvPr/>
+        </p:nvSpPr>
+        <p:spPr>
+          <a:xfrm>
+            <a:off x="731520" y="777240"/>
+            <a:ext cx="9144000" cy="274320"/>
+          </a:xfrm>
+          <a:prstGeom prst="rect">
+            <a:avLst/>
+          </a:prstGeom>
+          <a:noFill/>
+        </p:spPr>
+        <p:txBody>
+          <a:bodyPr wrap="square">
+            <a:spAutoFit/>
+          </a:bodyPr>
+          <a:lstStyle/>
+          <a:p>
             <a:pPr algn="l">
               <a:defRPr sz="1300" b="0">
                 <a:solidFill>
+                  <a:srgbClr val="007C91"/>
+                </a:solidFill>
+              </a:defRPr>
+            </a:pPr>
+            <a:r>
+              <a:t>Col 3 — Dated imaging studies</a:t>
+            </a:r>
+          </a:p>
+        </p:txBody>
+      </p:sp>
+      <p:sp>
+        <p:nvSpPr>
+          <p:cNvPr id="6" name="Rectangle 5"/>
+          <p:cNvSpPr/>
+          <p:nvPr/>
+        </p:nvSpPr>
+        <p:spPr>
+          <a:xfrm>
+            <a:off x="731520" y="1234440"/>
+            <a:ext cx="1371600" cy="45720"/>
+          </a:xfrm>
+          <a:prstGeom prst="rect">
+            <a:avLst/>
+          </a:prstGeom>
+          <a:solidFill>
+            <a:srgbClr val="007C91"/>
+          </a:solidFill>
+          <a:ln>
+            <a:noFill/>
+          </a:ln>
+        </p:spPr>
+        <p:style>
+          <a:lnRef idx="1">
+            <a:schemeClr val="accent1"/>
+          </a:lnRef>
+          <a:fillRef idx="3">
+            <a:schemeClr val="accent1"/>
+          </a:fillRef>
+          <a:effectRef idx="2">
+            <a:schemeClr val="accent1"/>
+          </a:effectRef>
+          <a:fontRef idx="minor">
+            <a:schemeClr val="lt1"/>
+          </a:fontRef>
+        </p:style>
+        <p:txBody>
+          <a:bodyPr rtlCol="0" anchor="ctr"/>
+          <a:lstStyle/>
+          <a:p>
+            <a:pPr algn="ctr"/>
+          </a:p>
+        </p:txBody>
+      </p:sp>
+      <p:sp>
+        <p:nvSpPr>
+          <p:cNvPr id="7" name="body"/>
+          <p:cNvSpPr txBox="1"/>
+          <p:nvPr/>
+        </p:nvSpPr>
+        <p:spPr>
+          <a:xfrm>
+            <a:off x="731520" y="1417320"/>
+            <a:ext cx="10515600" cy="4754880"/>
+          </a:xfrm>
+          <a:prstGeom prst="rect">
+            <a:avLst/>
+          </a:prstGeom>
+          <a:noFill/>
+        </p:spPr>
+        <p:txBody>
+          <a:bodyPr wrap="square">
+            <a:spAutoFit/>
+          </a:bodyPr>
+          <a:lstStyle/>
+          <a:p>
+            <a:pPr algn="l">
+              <a:defRPr sz="1300" b="0">
+                <a:solidFill>
                   <a:srgbClr val="333333"/>
                 </a:solidFill>
               </a:defRPr>
@@ -3821,6 +4325,389 @@
       <p:sp>
         <p:nvSpPr>
           <p:cNvPr id="8" name="footer"/>
+          <p:cNvSpPr txBox="1"/>
+          <p:nvPr/>
+        </p:nvSpPr>
+        <p:spPr>
+          <a:xfrm>
+            <a:off x="731520" y="6400800"/>
+            <a:ext cx="10515600" cy="365760"/>
+          </a:xfrm>
+          <a:prstGeom prst="rect">
+            <a:avLst/>
+          </a:prstGeom>
+          <a:noFill/>
+        </p:spPr>
+        <p:txBody>
+          <a:bodyPr wrap="square">
+            <a:spAutoFit/>
+          </a:bodyPr>
+          <a:lstStyle/>
+          <a:p>
+            <a:pPr algn="ctr">
+              <a:defRPr sz="1000" b="0">
+                <a:solidFill>
+                  <a:srgbClr val="999999"/>
+                </a:solidFill>
+              </a:defRPr>
+            </a:pPr>
+            <a:r>
+              <a:t>GYN Oncology Tumor Board</a:t>
+            </a:r>
+          </a:p>
+        </p:txBody>
+      </p:sp>
+    </p:spTree>
+  </p:cSld>
+  <p:clrMapOvr>
+    <a:masterClrMapping/>
+  </p:clrMapOvr>
+</p:sld>
+</file>
+
+<file path=ppt/slides/slide5.xml><?xml version="1.0" encoding="utf-8"?>
+<p:sld xmlns:a="http://schemas.openxmlformats.org/drawingml/2006/main" xmlns:p="http://schemas.openxmlformats.org/presentationml/2006/main" xmlns:r="http://schemas.openxmlformats.org/officeDocument/2006/relationships">
+  <p:cSld>
+    <p:bg>
+      <p:bgPr>
+        <a:solidFill>
+          <a:srgbClr val="FFFFFF"/>
+        </a:solidFill>
+        <a:effectLst/>
+      </p:bgPr>
+    </p:bg>
+    <p:spTree>
+      <p:nvGrpSpPr>
+        <p:cNvPr id="1" name=""/>
+        <p:cNvGrpSpPr/>
+        <p:nvPr/>
+      </p:nvGrpSpPr>
+      <p:grpSpPr/>
+      <p:sp>
+        <p:nvSpPr>
+          <p:cNvPr id="2" name="header_bar"/>
+          <p:cNvSpPr/>
+          <p:nvPr/>
+        </p:nvSpPr>
+        <p:spPr>
+          <a:xfrm>
+            <a:off x="0" y="0"/>
+            <a:ext cx="12191695" cy="1097280"/>
+          </a:xfrm>
+          <a:prstGeom prst="rect">
+            <a:avLst/>
+          </a:prstGeom>
+          <a:solidFill>
+            <a:srgbClr val="1B365D"/>
+          </a:solidFill>
+          <a:ln>
+            <a:noFill/>
+          </a:ln>
+        </p:spPr>
+        <p:style>
+          <a:lnRef idx="1">
+            <a:schemeClr val="accent1"/>
+          </a:lnRef>
+          <a:fillRef idx="3">
+            <a:schemeClr val="accent1"/>
+          </a:fillRef>
+          <a:effectRef idx="2">
+            <a:schemeClr val="accent1"/>
+          </a:effectRef>
+          <a:fontRef idx="minor">
+            <a:schemeClr val="lt1"/>
+          </a:fontRef>
+        </p:style>
+        <p:txBody>
+          <a:bodyPr rtlCol="0" anchor="ctr"/>
+          <a:lstStyle/>
+          <a:p>
+            <a:pPr algn="ctr"/>
+          </a:p>
+        </p:txBody>
+      </p:sp>
+      <p:sp>
+        <p:nvSpPr>
+          <p:cNvPr id="3" name="slide_badge"/>
+          <p:cNvSpPr txBox="1"/>
+          <p:nvPr/>
+        </p:nvSpPr>
+        <p:spPr>
+          <a:xfrm>
+            <a:off x="11002975" y="91440"/>
+            <a:ext cx="1097280" cy="320040"/>
+          </a:xfrm>
+          <a:prstGeom prst="rect">
+            <a:avLst/>
+          </a:prstGeom>
+          <a:noFill/>
+        </p:spPr>
+        <p:txBody>
+          <a:bodyPr wrap="none">
+            <a:spAutoFit/>
+          </a:bodyPr>
+          <a:lstStyle/>
+          <a:p>
+            <a:pPr algn="r">
+              <a:defRPr sz="1100">
+                <a:solidFill>
+                  <a:srgbClr val="007C91"/>
+                </a:solidFill>
+              </a:defRPr>
+            </a:pPr>
+            <a:r>
+              <a:t>5 / 5</a:t>
+            </a:r>
+          </a:p>
+        </p:txBody>
+      </p:sp>
+      <p:sp>
+        <p:nvSpPr>
+          <p:cNvPr id="4" name="title"/>
+          <p:cNvSpPr txBox="1"/>
+          <p:nvPr/>
+        </p:nvSpPr>
+        <p:spPr>
+          <a:xfrm>
+            <a:off x="731520" y="228600"/>
+            <a:ext cx="9144000" cy="548640"/>
+          </a:xfrm>
+          <a:prstGeom prst="rect">
+            <a:avLst/>
+          </a:prstGeom>
+          <a:noFill/>
+        </p:spPr>
+        <p:txBody>
+          <a:bodyPr wrap="square">
+            <a:spAutoFit/>
+          </a:bodyPr>
+          <a:lstStyle/>
+          <a:p>
+            <a:pPr algn="l">
+              <a:defRPr sz="3200" b="1">
+                <a:solidFill>
+                  <a:srgbClr val="FFFFFF"/>
+                </a:solidFill>
+              </a:defRPr>
+            </a:pPr>
+            <a:r>
+              <a:t>Discussion</a:t>
+            </a:r>
+          </a:p>
+        </p:txBody>
+      </p:sp>
+      <p:sp>
+        <p:nvSpPr>
+          <p:cNvPr id="5" name="subtitle"/>
+          <p:cNvSpPr txBox="1"/>
+          <p:nvPr/>
+        </p:nvSpPr>
+        <p:spPr>
+          <a:xfrm>
+            <a:off x="731520" y="777240"/>
+            <a:ext cx="9144000" cy="274320"/>
+          </a:xfrm>
+          <a:prstGeom prst="rect">
+            <a:avLst/>
+          </a:prstGeom>
+          <a:noFill/>
+        </p:spPr>
+        <p:txBody>
+          <a:bodyPr wrap="square">
+            <a:spAutoFit/>
+          </a:bodyPr>
+          <a:lstStyle/>
+          <a:p>
+            <a:pPr algn="l">
+              <a:defRPr sz="1300" b="0">
+                <a:solidFill>
+                  <a:srgbClr val="007C91"/>
+                </a:solidFill>
+              </a:defRPr>
+            </a:pPr>
+            <a:r>
+              <a:t>Col 4 — Review · Trial eligibility · Plan</a:t>
+            </a:r>
+          </a:p>
+        </p:txBody>
+      </p:sp>
+      <p:sp>
+        <p:nvSpPr>
+          <p:cNvPr id="6" name="Rectangle 5"/>
+          <p:cNvSpPr/>
+          <p:nvPr/>
+        </p:nvSpPr>
+        <p:spPr>
+          <a:xfrm>
+            <a:off x="731520" y="1234440"/>
+            <a:ext cx="1371600" cy="45720"/>
+          </a:xfrm>
+          <a:prstGeom prst="rect">
+            <a:avLst/>
+          </a:prstGeom>
+          <a:solidFill>
+            <a:srgbClr val="007C91"/>
+          </a:solidFill>
+          <a:ln>
+            <a:noFill/>
+          </a:ln>
+        </p:spPr>
+        <p:style>
+          <a:lnRef idx="1">
+            <a:schemeClr val="accent1"/>
+          </a:lnRef>
+          <a:fillRef idx="3">
+            <a:schemeClr val="accent1"/>
+          </a:fillRef>
+          <a:effectRef idx="2">
+            <a:schemeClr val="accent1"/>
+          </a:effectRef>
+          <a:fontRef idx="minor">
+            <a:schemeClr val="lt1"/>
+          </a:fontRef>
+        </p:style>
+        <p:txBody>
+          <a:bodyPr rtlCol="0" anchor="ctr"/>
+          <a:lstStyle/>
+          <a:p>
+            <a:pPr algn="ctr"/>
+          </a:p>
+        </p:txBody>
+      </p:sp>
+      <p:sp>
+        <p:nvSpPr>
+          <p:cNvPr id="7" name="review_header"/>
+          <p:cNvSpPr txBox="1"/>
+          <p:nvPr/>
+        </p:nvSpPr>
+        <p:spPr>
+          <a:xfrm>
+            <a:off x="731520" y="1417320"/>
+            <a:ext cx="10515600" cy="822960"/>
+          </a:xfrm>
+          <a:prstGeom prst="rect">
+            <a:avLst/>
+          </a:prstGeom>
+          <a:noFill/>
+        </p:spPr>
+        <p:txBody>
+          <a:bodyPr wrap="square">
+            <a:spAutoFit/>
+          </a:bodyPr>
+          <a:lstStyle/>
+          <a:p>
+            <a:pPr algn="l">
+              <a:defRPr sz="1400" b="0">
+                <a:solidFill>
+                  <a:srgbClr val="333333"/>
+                </a:solidFill>
+              </a:defRPr>
+            </a:pPr>
+          </a:p>
+        </p:txBody>
+      </p:sp>
+      <p:sp>
+        <p:nvSpPr>
+          <p:cNvPr id="8" name="body"/>
+          <p:cNvSpPr txBox="1"/>
+          <p:nvPr/>
+        </p:nvSpPr>
+        <p:spPr>
+          <a:xfrm>
+            <a:off x="731520" y="2331720"/>
+            <a:ext cx="10515600" cy="2560320"/>
+          </a:xfrm>
+          <a:prstGeom prst="rect">
+            <a:avLst/>
+          </a:prstGeom>
+          <a:noFill/>
+        </p:spPr>
+        <p:txBody>
+          <a:bodyPr wrap="square">
+            <a:spAutoFit/>
+          </a:bodyPr>
+          <a:lstStyle/>
+          <a:p>
+            <a:pPr algn="l">
+              <a:defRPr sz="1400" b="0">
+                <a:solidFill>
+                  <a:srgbClr val="333333"/>
+                </a:solidFill>
+              </a:defRPr>
+            </a:pPr>
+          </a:p>
+        </p:txBody>
+      </p:sp>
+      <p:sp>
+        <p:nvSpPr>
+          <p:cNvPr id="9" name="trials_header"/>
+          <p:cNvSpPr txBox="1"/>
+          <p:nvPr/>
+        </p:nvSpPr>
+        <p:spPr>
+          <a:xfrm>
+            <a:off x="731520" y="4983480"/>
+            <a:ext cx="10515600" cy="365760"/>
+          </a:xfrm>
+          <a:prstGeom prst="rect">
+            <a:avLst/>
+          </a:prstGeom>
+          <a:noFill/>
+        </p:spPr>
+        <p:txBody>
+          <a:bodyPr wrap="square">
+            <a:spAutoFit/>
+          </a:bodyPr>
+          <a:lstStyle/>
+          <a:p>
+            <a:pPr algn="l">
+              <a:defRPr sz="1600" b="1">
+                <a:solidFill>
+                  <a:srgbClr val="007C91"/>
+                </a:solidFill>
+              </a:defRPr>
+            </a:pPr>
+            <a:r>
+              <a:t>Eligible Clinical Trials</a:t>
+            </a:r>
+          </a:p>
+        </p:txBody>
+      </p:sp>
+      <p:sp>
+        <p:nvSpPr>
+          <p:cNvPr id="10" name="trials_body"/>
+          <p:cNvSpPr txBox="1"/>
+          <p:nvPr/>
+        </p:nvSpPr>
+        <p:spPr>
+          <a:xfrm>
+            <a:off x="731520" y="5440680"/>
+            <a:ext cx="10515600" cy="822960"/>
+          </a:xfrm>
+          <a:prstGeom prst="rect">
+            <a:avLst/>
+          </a:prstGeom>
+          <a:noFill/>
+        </p:spPr>
+        <p:txBody>
+          <a:bodyPr wrap="square">
+            <a:spAutoFit/>
+          </a:bodyPr>
+          <a:lstStyle/>
+          <a:p>
+            <a:pPr algn="l">
+              <a:defRPr sz="1300" b="0">
+                <a:solidFill>
+                  <a:srgbClr val="333333"/>
+                </a:solidFill>
+              </a:defRPr>
+            </a:pPr>
+          </a:p>
+        </p:txBody>
+      </p:sp>
+      <p:sp>
+        <p:nvSpPr>
+          <p:cNvPr id="11" name="footer"/>
           <p:cNvSpPr txBox="1"/>
           <p:nvPr/>
         </p:nvSpPr>

</xml_diff>